<commit_message>
AthDGC site update 2026-06-20 00:05 --- clean Quarto render, real Zenodo DOI 10.5281/zenodo.20439182, samples-only public release
</commit_message>
<xml_diff>
--- a/slides/tau_intertextuality_2026.pptx
+++ b/slides/tau_intertextuality_2026.pptx
@@ -7442,6 +7442,19 @@
             <a:r>
               <a:rPr/>
               <a:t>Three universities (NKUA · Oslo · Ghent); eleven researchers; one platform. HFRI Project No. 20577 · Greece 2.0 NRRP.</a:t>
+            </a:r>
+          </a:p>
+          <a:p>
+            <a:pPr lvl="0" indent="0" marL="0">
+              <a:buNone/>
+            </a:pPr>
+            <a:r>
+              <a:rPr b="1"/>
+              <a:t>AthDGC is the Athens node of the PROIEL family</a:t>
+            </a:r>
+            <a:r>
+              <a:rPr/>
+              <a:t> (“Athens-PROIEL”). Dag Haug, founding director of PROIEL at Oslo, is a co-author and co-PI. We adopt the PROIEL XML 2.0 schema verbatim and we extend it diachronically.</a:t>
             </a:r>
           </a:p>
         </p:txBody>

</xml_diff>